<commit_message>
Add presentation scripts (ZH/EN) and finalize slides
</commit_message>
<xml_diff>
--- a/report/presentation/group9_oss_pulse.pptx
+++ b/report/presentation/group9_oss_pulse.pptx
@@ -12405,8 +12405,8 @@
         </p:nvSpPr>
         <p:spPr>
           <a:xfrm>
-            <a:off x="5413572" y="1842516"/>
-            <a:ext cx="3318948" cy="2240280"/>
+            <a:off x="5413571" y="1842515"/>
+            <a:ext cx="3520035" cy="2509375"/>
           </a:xfrm>
           <a:prstGeom prst="roundRect">
             <a:avLst/>
@@ -12581,7 +12581,7 @@
         <p:spPr>
           <a:xfrm>
             <a:off x="5617029" y="2262088"/>
-            <a:ext cx="3004457" cy="1535805"/>
+            <a:ext cx="3236872" cy="1612749"/>
           </a:xfrm>
           <a:prstGeom prst="rect">
             <a:avLst/>
@@ -12601,13 +12601,61 @@
               <a:buNone/>
             </a:pPr>
             <a:r>
+              <a:rPr lang="en-US" sz="1100" b="1" dirty="0">
+                <a:solidFill>
+                  <a:srgbClr val="57068C"/>
+                </a:solidFill>
+              </a:rPr>
+              <a:t>Push share grew</a:t>
+            </a:r>
+            <a:r>
               <a:rPr sz="1100" b="1" i="0" dirty="0">
                 <a:solidFill>
                   <a:srgbClr val="57068C"/>
                 </a:solidFill>
                 <a:latin typeface="Arial"/>
               </a:rPr>
-              <a:t>Push holds steady   </a:t>
+              <a:t>   </a:t>
+            </a:r>
+            <a:r>
+              <a:rPr lang="en-US" sz="1100" b="1" i="0" dirty="0">
+                <a:solidFill>
+                  <a:srgbClr val="57068C"/>
+                </a:solidFill>
+                <a:latin typeface="Arial"/>
+              </a:rPr>
+              <a:t>          </a:t>
+            </a:r>
+            <a:r>
+              <a:rPr lang="en-US" sz="1050" dirty="0">
+                <a:solidFill>
+                  <a:srgbClr val="1E1E28"/>
+                </a:solidFill>
+              </a:rPr>
+              <a:t>71% → 85% of all events</a:t>
+            </a:r>
+            <a:endParaRPr sz="1050" b="1" i="0" dirty="0">
+              <a:solidFill>
+                <a:srgbClr val="129E9E"/>
+              </a:solidFill>
+              <a:latin typeface="Arial"/>
+            </a:endParaRPr>
+          </a:p>
+          <a:p>
+            <a:pPr marL="0" indent="0">
+              <a:spcAft>
+                <a:spcPts val="400"/>
+              </a:spcAft>
+              <a:buNone/>
+            </a:pPr>
+            <a:r>
+              <a:rPr sz="1100" b="1" i="0" dirty="0">
+                <a:solidFill>
+                  <a:srgbClr val="57068C"/>
+                </a:solidFill>
+                <a:latin typeface="Arial"/>
+              </a:rPr>
+              <a:t>Watch (Star) collapses   </a:t>
             </a:r>
             <a:r>
               <a:rPr sz="1050" b="0" i="0" dirty="0">
@@ -12616,22 +12664,22 @@
                 </a:solidFill>
                 <a:latin typeface="Arial"/>
               </a:rPr>
-              <a:t>146 M  →  225 M  </a:t>
+              <a:t>19.6 M  →  7.2 M  </a:t>
             </a:r>
             <a:r>
               <a:rPr sz="1050" b="1" i="0" dirty="0">
                 <a:solidFill>
-                  <a:srgbClr val="129E9E"/>
-                </a:solidFill>
-                <a:latin typeface="Arial"/>
-              </a:rPr>
-              <a:t>(+54%)</a:t>
+                  <a:srgbClr val="E24A4A"/>
+                </a:solidFill>
+                <a:latin typeface="Arial"/>
+              </a:rPr>
+              <a:t>(−63%)</a:t>
             </a:r>
           </a:p>
           <a:p>
             <a:pPr marL="0" indent="0">
               <a:spcAft>
-                <a:spcPts val="400"/>
+                <a:spcPts val="1000"/>
               </a:spcAft>
               <a:buNone/>
             </a:pPr>
@@ -12642,7 +12690,16 @@
                 </a:solidFill>
                 <a:latin typeface="Arial"/>
               </a:rPr>
-              <a:t>Watch (Star) collapses   </a:t>
+              <a:t>Fork collapses   </a:t>
+            </a:r>
+            <a:r>
+              <a:rPr lang="en-US" sz="1100" b="1" i="0" dirty="0">
+                <a:solidFill>
+                  <a:srgbClr val="57068C"/>
+                </a:solidFill>
+                <a:latin typeface="Arial"/>
+              </a:rPr>
+              <a:t>              </a:t>
             </a:r>
             <a:r>
               <a:rPr sz="1050" b="0" i="0" dirty="0">
@@ -12651,7 +12708,7 @@
                 </a:solidFill>
                 <a:latin typeface="Arial"/>
               </a:rPr>
-              <a:t>19.6 M  →  7.2 M  </a:t>
+              <a:t>4.6 M  →  1.5 M  </a:t>
             </a:r>
             <a:r>
               <a:rPr sz="1050" b="1" i="0" dirty="0">
@@ -12660,42 +12717,23 @@
                 </a:solidFill>
                 <a:latin typeface="Arial"/>
               </a:rPr>
-              <a:t>(−63%)</a:t>
+              <a:t>(−67%)</a:t>
             </a:r>
           </a:p>
           <a:p>
             <a:pPr marL="0" indent="0">
               <a:spcAft>
-                <a:spcPts val="1000"/>
-              </a:spcAft>
-              <a:buNone/>
-            </a:pPr>
-            <a:r>
-              <a:rPr sz="1100" b="1" i="0" dirty="0">
-                <a:solidFill>
-                  <a:srgbClr val="57068C"/>
-                </a:solidFill>
-                <a:latin typeface="Arial"/>
-              </a:rPr>
-              <a:t>Fork collapses   </a:t>
-            </a:r>
-            <a:r>
-              <a:rPr sz="1050" b="0" i="0" dirty="0">
+                <a:spcPts val="600"/>
+              </a:spcAft>
+              <a:buNone/>
+            </a:pPr>
+            <a:r>
+              <a:rPr lang="en-US" sz="1050" i="1" dirty="0">
                 <a:solidFill>
                   <a:srgbClr val="1E1E28"/>
                 </a:solidFill>
-                <a:latin typeface="Arial"/>
-              </a:rPr>
-              <a:t>4.6 M  →  1.5 M  </a:t>
-            </a:r>
-            <a:r>
-              <a:rPr sz="1050" b="1" i="0" dirty="0">
-                <a:solidFill>
-                  <a:srgbClr val="E24A4A"/>
-                </a:solidFill>
-                <a:latin typeface="Arial"/>
-              </a:rPr>
-              <a:t>(−67%)</a:t>
+              </a:rPr>
+              <a:t>2026 total events fell 29% from 2025 peak — driven by GitHub's removal of inauthentic accounts.</a:t>
             </a:r>
           </a:p>
           <a:p>
@@ -12711,7 +12749,7 @@
                   <a:srgbClr val="1E1E28"/>
                 </a:solidFill>
               </a:rPr>
-              <a:t>GitHub's removal of inauthentic accounts.                                                                                                                 </a:t>
+              <a:t>Popularity signals were hit hardest;</a:t>
             </a:r>
           </a:p>
           <a:p>
@@ -12722,28 +12760,20 @@
               <a:buNone/>
             </a:pPr>
             <a:r>
+              <a:rPr lang="en-US" sz="1050" i="1">
+                <a:solidFill>
+                  <a:srgbClr val="1E1E28"/>
+                </a:solidFill>
+              </a:rPr>
+              <a:t>push </a:t>
+            </a:r>
+            <a:r>
               <a:rPr lang="en-US" sz="1050" i="1" dirty="0">
                 <a:solidFill>
                   <a:srgbClr val="1E1E28"/>
                 </a:solidFill>
               </a:rPr>
-              <a:t>Social signals were hit hardest; push (engineering activity) </a:t>
-            </a:r>
-            <a:r>
-              <a:rPr lang="zh-TW" altLang="en-US" sz="1050" i="1" dirty="0">
-                <a:solidFill>
-                  <a:srgbClr val="1E1E28"/>
-                </a:solidFill>
-              </a:rPr>
-              <a:t> </a:t>
-            </a:r>
-            <a:r>
-              <a:rPr lang="en-US" sz="1050" i="1" dirty="0">
-                <a:solidFill>
-                  <a:srgbClr val="1E1E28"/>
-                </a:solidFill>
-              </a:rPr>
-              <a:t>fell least. </a:t>
+              <a:t>(engineering activity) fell least.</a:t>
             </a:r>
             <a:endParaRPr sz="1050" b="1" i="1" dirty="0">
               <a:solidFill>

</xml_diff>